<commit_message>
doc: re-render the ec2-intro showcase output
</commit_message>
<xml_diff>
--- a/examples/showcase/decks/ec2-intro/what-is-amazon-ec2.pptx
+++ b/examples/showcase/decks/ec2-intro/what-is-amazon-ec2.pptx
@@ -16319,9 +16319,18 @@
               </a:path>
             </a:pathLst>
           </a:custGeom>
-          <a:solidFill>
-            <a:schemeClr val="bg2"/>
-          </a:solidFill>
+          <a:pattFill prst="wdUpDiag">
+            <a:fgClr>
+              <a:schemeClr val="tx2">
+                <a:alpha val="35000"/>
+              </a:schemeClr>
+            </a:fgClr>
+            <a:bgClr>
+              <a:schemeClr val="bg1">
+                <a:alpha val="0"/>
+              </a:schemeClr>
+            </a:bgClr>
+          </a:pattFill>
           <a:ln>
             <a:noFill/>
           </a:ln>
@@ -16453,14 +16462,43 @@
       </p:sp>
       <p:sp>
         <p:nvSpPr>
-          <p:cNvPr id="9" name="text s2.2.0.0.2.0"/>
+          <p:cNvPr id="9" name="shape s2.2.0.0.2.0.0"/>
+          <p:cNvSpPr/>
+          <p:nvPr/>
+        </p:nvSpPr>
+        <p:spPr>
+          <a:xfrm>
+            <a:off x="985838" y="4766370"/>
+            <a:ext cx="171450" cy="28575"/>
+          </a:xfrm>
+          <a:prstGeom prst="rect">
+            <a:avLst/>
+          </a:prstGeom>
+          <a:solidFill>
+            <a:schemeClr val="tx1"/>
+          </a:solidFill>
+          <a:ln>
+            <a:noFill/>
+          </a:ln>
+        </p:spPr>
+        <p:txBody>
+          <a:bodyPr wrap="square" lIns="0" tIns="0" rIns="0" bIns="0" anchor="t">
+            <a:normAutofit/>
+          </a:bodyPr>
+          <a:lstStyle/>
+          <a:p/>
+        </p:txBody>
+      </p:sp>
+      <p:sp>
+        <p:nvSpPr>
+          <p:cNvPr id="10" name="text s2.2.0.0.2.0.1"/>
           <p:cNvSpPr txBox="1"/>
           <p:nvPr/>
         </p:nvSpPr>
         <p:spPr>
           <a:xfrm>
-            <a:off x="985838" y="4660702"/>
-            <a:ext cx="905768" cy="239911"/>
+            <a:off x="1214438" y="4660702"/>
+            <a:ext cx="689818" cy="239911"/>
           </a:xfrm>
           <a:prstGeom prst="rect">
             <a:avLst/>
@@ -16482,16 +16520,6 @@
               </a:lnSpc>
             </a:pPr>
             <a:r>
-              <a:rPr sz="1350" b="1" i="0" u="none">
-                <a:solidFill>
-                  <a:schemeClr val="tx2"/>
-                </a:solidFill>
-                <a:latin typeface="+mn-lt"/>
-                <a:ea typeface="+mn-ea"/>
-              </a:rPr>
-              <a:t>━</a:t>
-            </a:r>
-            <a:r>
               <a:rPr sz="1350" b="0">
                 <a:solidFill>
                   <a:schemeClr val="tx2"/>
@@ -16499,21 +16527,50 @@
                 <a:latin typeface="+mn-lt"/>
                 <a:ea typeface="+mn-ea"/>
               </a:rPr>
-              <a:t> Demand</a:t>
+              <a:t>Demand</a:t>
             </a:r>
           </a:p>
         </p:txBody>
       </p:sp>
       <p:sp>
         <p:nvSpPr>
-          <p:cNvPr id="10" name="text s2.2.0.0.2.1"/>
+          <p:cNvPr id="11" name="shape s2.2.0.0.2.1.0"/>
+          <p:cNvSpPr/>
+          <p:nvPr/>
+        </p:nvSpPr>
+        <p:spPr>
+          <a:xfrm>
+            <a:off x="2132856" y="4771132"/>
+            <a:ext cx="171450" cy="19050"/>
+          </a:xfrm>
+          <a:prstGeom prst="rect">
+            <a:avLst/>
+          </a:prstGeom>
+          <a:solidFill>
+            <a:schemeClr val="tx2"/>
+          </a:solidFill>
+          <a:ln>
+            <a:noFill/>
+          </a:ln>
+        </p:spPr>
+        <p:txBody>
+          <a:bodyPr wrap="square" lIns="0" tIns="0" rIns="0" bIns="0" anchor="t">
+            <a:normAutofit/>
+          </a:bodyPr>
+          <a:lstStyle/>
+          <a:p/>
+        </p:txBody>
+      </p:sp>
+      <p:sp>
+        <p:nvSpPr>
+          <p:cNvPr id="12" name="text s2.2.0.0.2.1.1"/>
           <p:cNvSpPr txBox="1"/>
           <p:nvPr/>
         </p:nvSpPr>
         <p:spPr>
           <a:xfrm>
-            <a:off x="2120205" y="4660702"/>
-            <a:ext cx="1156990" cy="239911"/>
+            <a:off x="2361456" y="4660702"/>
+            <a:ext cx="941040" cy="239911"/>
           </a:xfrm>
           <a:prstGeom prst="rect">
             <a:avLst/>
@@ -16535,16 +16592,6 @@
               </a:lnSpc>
             </a:pPr>
             <a:r>
-              <a:rPr sz="1350" b="1" i="0" u="none">
-                <a:solidFill>
-                  <a:schemeClr val="tx2"/>
-                </a:solidFill>
-                <a:latin typeface="+mn-lt"/>
-                <a:ea typeface="+mn-ea"/>
-              </a:rPr>
-              <a:t>━</a:t>
-            </a:r>
-            <a:r>
               <a:rPr sz="1350" b="0">
                 <a:solidFill>
                   <a:schemeClr val="tx2"/>
@@ -16552,21 +16599,62 @@
                 <a:latin typeface="+mn-lt"/>
                 <a:ea typeface="+mn-ea"/>
               </a:rPr>
-              <a:t> Provisioned</a:t>
+              <a:t>Provisioned</a:t>
             </a:r>
           </a:p>
         </p:txBody>
       </p:sp>
       <p:sp>
         <p:nvSpPr>
-          <p:cNvPr id="11" name="text s2.2.0.0.2.2"/>
+          <p:cNvPr id="13" name="shape s2.2.0.0.2.2.0"/>
+          <p:cNvSpPr/>
+          <p:nvPr/>
+        </p:nvSpPr>
+        <p:spPr>
+          <a:xfrm>
+            <a:off x="3531096" y="4713982"/>
+            <a:ext cx="133350" cy="133350"/>
+          </a:xfrm>
+          <a:prstGeom prst="rect">
+            <a:avLst/>
+          </a:prstGeom>
+          <a:pattFill prst="wdUpDiag">
+            <a:fgClr>
+              <a:schemeClr val="tx2">
+                <a:alpha val="60000"/>
+              </a:schemeClr>
+            </a:fgClr>
+            <a:bgClr>
+              <a:schemeClr val="bg1">
+                <a:alpha val="0"/>
+              </a:schemeClr>
+            </a:bgClr>
+          </a:pattFill>
+          <a:ln w="9525">
+            <a:solidFill>
+              <a:schemeClr val="tx2"/>
+            </a:solidFill>
+            <a:prstDash val="solid"/>
+          </a:ln>
+        </p:spPr>
+        <p:txBody>
+          <a:bodyPr wrap="square" lIns="0" tIns="0" rIns="0" bIns="0" anchor="t">
+            <a:normAutofit/>
+          </a:bodyPr>
+          <a:lstStyle/>
+          <a:p/>
+        </p:txBody>
+      </p:sp>
+      <p:sp>
+        <p:nvSpPr>
+          <p:cNvPr id="14" name="text s2.2.0.0.2.2.1"/>
           <p:cNvSpPr txBox="1"/>
           <p:nvPr/>
         </p:nvSpPr>
         <p:spPr>
           <a:xfrm>
-            <a:off x="3505795" y="4660702"/>
-            <a:ext cx="1221135" cy="239911"/>
+            <a:off x="3721596" y="4660702"/>
+            <a:ext cx="1005036" cy="239911"/>
           </a:xfrm>
           <a:prstGeom prst="rect">
             <a:avLst/>
@@ -16588,16 +16676,6 @@
               </a:lnSpc>
             </a:pPr>
             <a:r>
-              <a:rPr sz="1350" b="1" i="0" u="none">
-                <a:solidFill>
-                  <a:schemeClr val="tx2"/>
-                </a:solidFill>
-                <a:latin typeface="+mn-lt"/>
-                <a:ea typeface="+mn-ea"/>
-              </a:rPr>
-              <a:t>■</a:t>
-            </a:r>
-            <a:r>
               <a:rPr sz="1350" b="0">
                 <a:solidFill>
                   <a:schemeClr val="tx2"/>
@@ -16605,14 +16683,14 @@
                 <a:latin typeface="+mn-lt"/>
                 <a:ea typeface="+mn-ea"/>
               </a:rPr>
-              <a:t> Idle capacity</a:t>
+              <a:t>Idle capacity</a:t>
             </a:r>
           </a:p>
         </p:txBody>
       </p:sp>
       <p:sp>
         <p:nvSpPr>
-          <p:cNvPr id="12" name="p s2.2.0.0.3"/>
+          <p:cNvPr id="15" name="p s2.2.0.0.3"/>
           <p:cNvSpPr txBox="1"/>
           <p:nvPr/>
         </p:nvSpPr>
@@ -16695,7 +16773,7 @@
       </p:sp>
       <p:sp>
         <p:nvSpPr>
-          <p:cNvPr id="13" name="shape s2.2.1"/>
+          <p:cNvPr id="16" name="shape s2.2.1"/>
           <p:cNvSpPr/>
           <p:nvPr/>
         </p:nvSpPr>
@@ -16736,7 +16814,7 @@
       </p:sp>
       <p:sp>
         <p:nvSpPr>
-          <p:cNvPr id="14" name="h3 s2.2.1.0.0"/>
+          <p:cNvPr id="17" name="h3 s2.2.1.0.0"/>
           <p:cNvSpPr txBox="1"/>
           <p:nvPr/>
         </p:nvSpPr>
@@ -16779,7 +16857,7 @@
       </p:sp>
       <p:sp>
         <p:nvSpPr>
-          <p:cNvPr id="15" name="shape s2.2.1.0.1.0"/>
+          <p:cNvPr id="18" name="shape s2.2.1.0.1.0"/>
           <p:cNvSpPr/>
           <p:nvPr/>
         </p:nvSpPr>
@@ -16886,7 +16964,7 @@
       </p:sp>
       <p:sp>
         <p:nvSpPr>
-          <p:cNvPr id="16" name="shape s2.2.1.0.1.1"/>
+          <p:cNvPr id="19" name="shape s2.2.1.0.1.1"/>
           <p:cNvSpPr/>
           <p:nvPr/>
         </p:nvSpPr>
@@ -16984,7 +17062,7 @@
       </p:sp>
       <p:sp>
         <p:nvSpPr>
-          <p:cNvPr id="17" name="shape s2.2.1.0.1.2"/>
+          <p:cNvPr id="20" name="shape s2.2.1.0.1.2"/>
           <p:cNvSpPr/>
           <p:nvPr/>
         </p:nvSpPr>
@@ -17045,14 +17123,43 @@
       </p:sp>
       <p:sp>
         <p:nvSpPr>
-          <p:cNvPr id="18" name="text s2.2.1.0.2.0"/>
+          <p:cNvPr id="21" name="shape s2.2.1.0.2.0.0"/>
+          <p:cNvSpPr/>
+          <p:nvPr/>
+        </p:nvSpPr>
+        <p:spPr>
+          <a:xfrm>
+            <a:off x="6643688" y="4766370"/>
+            <a:ext cx="171450" cy="28575"/>
+          </a:xfrm>
+          <a:prstGeom prst="rect">
+            <a:avLst/>
+          </a:prstGeom>
+          <a:solidFill>
+            <a:schemeClr val="tx1"/>
+          </a:solidFill>
+          <a:ln>
+            <a:noFill/>
+          </a:ln>
+        </p:spPr>
+        <p:txBody>
+          <a:bodyPr wrap="square" lIns="0" tIns="0" rIns="0" bIns="0" anchor="t">
+            <a:normAutofit/>
+          </a:bodyPr>
+          <a:lstStyle/>
+          <a:p/>
+        </p:txBody>
+      </p:sp>
+      <p:sp>
+        <p:nvSpPr>
+          <p:cNvPr id="22" name="text s2.2.1.0.2.0.1"/>
           <p:cNvSpPr txBox="1"/>
           <p:nvPr/>
         </p:nvSpPr>
         <p:spPr>
           <a:xfrm>
-            <a:off x="6643688" y="4660702"/>
-            <a:ext cx="905768" cy="239911"/>
+            <a:off x="6872288" y="4660702"/>
+            <a:ext cx="689818" cy="239911"/>
           </a:xfrm>
           <a:prstGeom prst="rect">
             <a:avLst/>
@@ -17074,16 +17181,6 @@
               </a:lnSpc>
             </a:pPr>
             <a:r>
-              <a:rPr sz="1350" b="1" i="0" u="none">
-                <a:solidFill>
-                  <a:schemeClr val="tx2"/>
-                </a:solidFill>
-                <a:latin typeface="+mn-lt"/>
-                <a:ea typeface="+mn-ea"/>
-              </a:rPr>
-              <a:t>━</a:t>
-            </a:r>
-            <a:r>
               <a:rPr sz="1350" b="0">
                 <a:solidFill>
                   <a:schemeClr val="tx2"/>
@@ -17091,21 +17188,50 @@
                 <a:latin typeface="+mn-lt"/>
                 <a:ea typeface="+mn-ea"/>
               </a:rPr>
-              <a:t> Demand</a:t>
+              <a:t>Demand</a:t>
             </a:r>
           </a:p>
         </p:txBody>
       </p:sp>
       <p:sp>
         <p:nvSpPr>
-          <p:cNvPr id="19" name="text s2.2.1.0.2.1"/>
+          <p:cNvPr id="23" name="shape s2.2.1.0.2.1.0"/>
+          <p:cNvSpPr/>
+          <p:nvPr/>
+        </p:nvSpPr>
+        <p:spPr>
+          <a:xfrm>
+            <a:off x="7790706" y="4771132"/>
+            <a:ext cx="171450" cy="19050"/>
+          </a:xfrm>
+          <a:prstGeom prst="rect">
+            <a:avLst/>
+          </a:prstGeom>
+          <a:solidFill>
+            <a:schemeClr val="accent1"/>
+          </a:solidFill>
+          <a:ln>
+            <a:noFill/>
+          </a:ln>
+        </p:spPr>
+        <p:txBody>
+          <a:bodyPr wrap="square" lIns="0" tIns="0" rIns="0" bIns="0" anchor="t">
+            <a:normAutofit/>
+          </a:bodyPr>
+          <a:lstStyle/>
+          <a:p/>
+        </p:txBody>
+      </p:sp>
+      <p:sp>
+        <p:nvSpPr>
+          <p:cNvPr id="24" name="text s2.2.1.0.2.1.1"/>
           <p:cNvSpPr txBox="1"/>
           <p:nvPr/>
         </p:nvSpPr>
         <p:spPr>
           <a:xfrm>
-            <a:off x="7778055" y="4660702"/>
-            <a:ext cx="1218456" cy="239911"/>
+            <a:off x="8019306" y="4660702"/>
+            <a:ext cx="1002357" cy="239911"/>
           </a:xfrm>
           <a:prstGeom prst="rect">
             <a:avLst/>
@@ -17127,16 +17253,6 @@
               </a:lnSpc>
             </a:pPr>
             <a:r>
-              <a:rPr sz="1350" b="1" i="0" u="none">
-                <a:solidFill>
-                  <a:schemeClr val="accent1"/>
-                </a:solidFill>
-                <a:latin typeface="+mn-lt"/>
-                <a:ea typeface="+mn-ea"/>
-              </a:rPr>
-              <a:t>━</a:t>
-            </a:r>
-            <a:r>
               <a:rPr sz="1350" b="0">
                 <a:solidFill>
                   <a:schemeClr val="accent1"/>
@@ -17144,21 +17260,53 @@
                 <a:latin typeface="+mn-lt"/>
                 <a:ea typeface="+mn-ea"/>
               </a:rPr>
-              <a:t> EC2 capacity</a:t>
+              <a:t>EC2 capacity</a:t>
             </a:r>
           </a:p>
         </p:txBody>
       </p:sp>
       <p:sp>
         <p:nvSpPr>
-          <p:cNvPr id="20" name="text s2.2.1.0.2.2"/>
+          <p:cNvPr id="25" name="shape s2.2.1.0.2.2.0"/>
+          <p:cNvSpPr/>
+          <p:nvPr/>
+        </p:nvSpPr>
+        <p:spPr>
+          <a:xfrm>
+            <a:off x="9250263" y="4713982"/>
+            <a:ext cx="133350" cy="133350"/>
+          </a:xfrm>
+          <a:prstGeom prst="rect">
+            <a:avLst/>
+          </a:prstGeom>
+          <a:solidFill>
+            <a:schemeClr val="accent1">
+              <a:lumMod val="20000"/>
+              <a:lumOff val="80000"/>
+            </a:schemeClr>
+          </a:solidFill>
+          <a:ln>
+            <a:noFill/>
+          </a:ln>
+        </p:spPr>
+        <p:txBody>
+          <a:bodyPr wrap="square" lIns="0" tIns="0" rIns="0" bIns="0" anchor="t">
+            <a:normAutofit/>
+          </a:bodyPr>
+          <a:lstStyle/>
+          <a:p/>
+        </p:txBody>
+      </p:sp>
+      <p:sp>
+        <p:nvSpPr>
+          <p:cNvPr id="26" name="text s2.2.1.0.2.2.1"/>
           <p:cNvSpPr txBox="1"/>
           <p:nvPr/>
         </p:nvSpPr>
         <p:spPr>
           <a:xfrm>
-            <a:off x="9225111" y="4660702"/>
-            <a:ext cx="1539180" cy="239911"/>
+            <a:off x="9440763" y="4660702"/>
+            <a:ext cx="1323082" cy="239911"/>
           </a:xfrm>
           <a:prstGeom prst="rect">
             <a:avLst/>
@@ -17180,16 +17328,6 @@
               </a:lnSpc>
             </a:pPr>
             <a:r>
-              <a:rPr sz="1350" b="1" i="0" u="none">
-                <a:solidFill>
-                  <a:schemeClr val="accent1"/>
-                </a:solidFill>
-                <a:latin typeface="+mn-lt"/>
-                <a:ea typeface="+mn-ea"/>
-              </a:rPr>
-              <a:t>■</a:t>
-            </a:r>
-            <a:r>
               <a:rPr sz="1350" b="0">
                 <a:solidFill>
                   <a:schemeClr val="accent1"/>
@@ -17197,14 +17335,14 @@
                 <a:latin typeface="+mn-lt"/>
                 <a:ea typeface="+mn-ea"/>
               </a:rPr>
-              <a:t> Small headroom</a:t>
+              <a:t>Small headroom</a:t>
             </a:r>
           </a:p>
         </p:txBody>
       </p:sp>
       <p:sp>
         <p:nvSpPr>
-          <p:cNvPr id="21" name="p s2.2.1.0.3"/>
+          <p:cNvPr id="27" name="p s2.2.1.0.3"/>
           <p:cNvSpPr txBox="1"/>
           <p:nvPr/>
         </p:nvSpPr>
@@ -17287,7 +17425,7 @@
       </p:sp>
       <p:sp>
         <p:nvSpPr>
-          <p:cNvPr id="22" name="chrome footer"/>
+          <p:cNvPr id="28" name="chrome footer"/>
           <p:cNvSpPr txBox="1"/>
           <p:nvPr/>
         </p:nvSpPr>
@@ -17330,7 +17468,7 @@
       </p:sp>
       <p:sp>
         <p:nvSpPr>
-          <p:cNvPr id="23" name="chrome pageNumber"/>
+          <p:cNvPr id="29" name="chrome pageNumber"/>
           <p:cNvSpPr txBox="1"/>
           <p:nvPr/>
         </p:nvSpPr>
@@ -19032,6 +19170,492 @@
                                   </p:childTnLst>
                                 </p:cTn>
                               </p:par>
+                              <p:par>
+                                <p:cTn id="105" presetID="42" presetClass="entr" presetSubtype="0" fill="hold" grpId="0" nodeType="withEffect">
+                                  <p:stCondLst>
+                                    <p:cond delay="330"/>
+                                  </p:stCondLst>
+                                  <p:childTnLst>
+                                    <p:set>
+                                      <p:cBhvr>
+                                        <p:cTn id="106" dur="1" fill="hold">
+                                          <p:stCondLst>
+                                            <p:cond delay="0"/>
+                                          </p:stCondLst>
+                                        </p:cTn>
+                                        <p:tgtEl>
+                                          <p:spTgt spid="22"/>
+                                        </p:tgtEl>
+                                        <p:attrNameLst>
+                                          <p:attrName>style.visibility</p:attrName>
+                                        </p:attrNameLst>
+                                      </p:cBhvr>
+                                      <p:to>
+                                        <p:strVal val="visible"/>
+                                      </p:to>
+                                    </p:set>
+                                    <p:animEffect transition="in" filter="fade">
+                                      <p:cBhvr>
+                                        <p:cTn id="107" dur="600"/>
+                                        <p:tgtEl>
+                                          <p:spTgt spid="22"/>
+                                        </p:tgtEl>
+                                      </p:cBhvr>
+                                    </p:animEffect>
+                                    <p:anim calcmode="lin" valueType="num">
+                                      <p:cBhvr>
+                                        <p:cTn id="108" dur="600" decel="100000" fill="hold"/>
+                                        <p:tgtEl>
+                                          <p:spTgt spid="22"/>
+                                        </p:tgtEl>
+                                        <p:attrNameLst>
+                                          <p:attrName>ppt_x</p:attrName>
+                                        </p:attrNameLst>
+                                      </p:cBhvr>
+                                      <p:tavLst>
+                                        <p:tav tm="0">
+                                          <p:val>
+                                            <p:strVal val="#ppt_x"/>
+                                          </p:val>
+                                        </p:tav>
+                                        <p:tav tm="100000">
+                                          <p:val>
+                                            <p:strVal val="#ppt_x"/>
+                                          </p:val>
+                                        </p:tav>
+                                      </p:tavLst>
+                                    </p:anim>
+                                    <p:anim calcmode="lin" valueType="num">
+                                      <p:cBhvr>
+                                        <p:cTn id="109" dur="600" decel="100000" fill="hold"/>
+                                        <p:tgtEl>
+                                          <p:spTgt spid="22"/>
+                                        </p:tgtEl>
+                                        <p:attrNameLst>
+                                          <p:attrName>ppt_y</p:attrName>
+                                        </p:attrNameLst>
+                                      </p:cBhvr>
+                                      <p:tavLst>
+                                        <p:tav tm="0">
+                                          <p:val>
+                                            <p:strVal val="#ppt_y+0.0333"/>
+                                          </p:val>
+                                        </p:tav>
+                                        <p:tav tm="100000">
+                                          <p:val>
+                                            <p:strVal val="#ppt_y"/>
+                                          </p:val>
+                                        </p:tav>
+                                      </p:tavLst>
+                                    </p:anim>
+                                  </p:childTnLst>
+                                </p:cTn>
+                              </p:par>
+                              <p:par>
+                                <p:cTn id="110" presetID="42" presetClass="entr" presetSubtype="0" fill="hold" grpId="0" nodeType="withEffect">
+                                  <p:stCondLst>
+                                    <p:cond delay="330"/>
+                                  </p:stCondLst>
+                                  <p:childTnLst>
+                                    <p:set>
+                                      <p:cBhvr>
+                                        <p:cTn id="111" dur="1" fill="hold">
+                                          <p:stCondLst>
+                                            <p:cond delay="0"/>
+                                          </p:stCondLst>
+                                        </p:cTn>
+                                        <p:tgtEl>
+                                          <p:spTgt spid="23"/>
+                                        </p:tgtEl>
+                                        <p:attrNameLst>
+                                          <p:attrName>style.visibility</p:attrName>
+                                        </p:attrNameLst>
+                                      </p:cBhvr>
+                                      <p:to>
+                                        <p:strVal val="visible"/>
+                                      </p:to>
+                                    </p:set>
+                                    <p:animEffect transition="in" filter="fade">
+                                      <p:cBhvr>
+                                        <p:cTn id="112" dur="600"/>
+                                        <p:tgtEl>
+                                          <p:spTgt spid="23"/>
+                                        </p:tgtEl>
+                                      </p:cBhvr>
+                                    </p:animEffect>
+                                    <p:anim calcmode="lin" valueType="num">
+                                      <p:cBhvr>
+                                        <p:cTn id="113" dur="600" decel="100000" fill="hold"/>
+                                        <p:tgtEl>
+                                          <p:spTgt spid="23"/>
+                                        </p:tgtEl>
+                                        <p:attrNameLst>
+                                          <p:attrName>ppt_x</p:attrName>
+                                        </p:attrNameLst>
+                                      </p:cBhvr>
+                                      <p:tavLst>
+                                        <p:tav tm="0">
+                                          <p:val>
+                                            <p:strVal val="#ppt_x"/>
+                                          </p:val>
+                                        </p:tav>
+                                        <p:tav tm="100000">
+                                          <p:val>
+                                            <p:strVal val="#ppt_x"/>
+                                          </p:val>
+                                        </p:tav>
+                                      </p:tavLst>
+                                    </p:anim>
+                                    <p:anim calcmode="lin" valueType="num">
+                                      <p:cBhvr>
+                                        <p:cTn id="114" dur="600" decel="100000" fill="hold"/>
+                                        <p:tgtEl>
+                                          <p:spTgt spid="23"/>
+                                        </p:tgtEl>
+                                        <p:attrNameLst>
+                                          <p:attrName>ppt_y</p:attrName>
+                                        </p:attrNameLst>
+                                      </p:cBhvr>
+                                      <p:tavLst>
+                                        <p:tav tm="0">
+                                          <p:val>
+                                            <p:strVal val="#ppt_y+0.0333"/>
+                                          </p:val>
+                                        </p:tav>
+                                        <p:tav tm="100000">
+                                          <p:val>
+                                            <p:strVal val="#ppt_y"/>
+                                          </p:val>
+                                        </p:tav>
+                                      </p:tavLst>
+                                    </p:anim>
+                                  </p:childTnLst>
+                                </p:cTn>
+                              </p:par>
+                              <p:par>
+                                <p:cTn id="115" presetID="42" presetClass="entr" presetSubtype="0" fill="hold" grpId="0" nodeType="withEffect">
+                                  <p:stCondLst>
+                                    <p:cond delay="330"/>
+                                  </p:stCondLst>
+                                  <p:childTnLst>
+                                    <p:set>
+                                      <p:cBhvr>
+                                        <p:cTn id="116" dur="1" fill="hold">
+                                          <p:stCondLst>
+                                            <p:cond delay="0"/>
+                                          </p:stCondLst>
+                                        </p:cTn>
+                                        <p:tgtEl>
+                                          <p:spTgt spid="24"/>
+                                        </p:tgtEl>
+                                        <p:attrNameLst>
+                                          <p:attrName>style.visibility</p:attrName>
+                                        </p:attrNameLst>
+                                      </p:cBhvr>
+                                      <p:to>
+                                        <p:strVal val="visible"/>
+                                      </p:to>
+                                    </p:set>
+                                    <p:animEffect transition="in" filter="fade">
+                                      <p:cBhvr>
+                                        <p:cTn id="117" dur="600"/>
+                                        <p:tgtEl>
+                                          <p:spTgt spid="24"/>
+                                        </p:tgtEl>
+                                      </p:cBhvr>
+                                    </p:animEffect>
+                                    <p:anim calcmode="lin" valueType="num">
+                                      <p:cBhvr>
+                                        <p:cTn id="118" dur="600" decel="100000" fill="hold"/>
+                                        <p:tgtEl>
+                                          <p:spTgt spid="24"/>
+                                        </p:tgtEl>
+                                        <p:attrNameLst>
+                                          <p:attrName>ppt_x</p:attrName>
+                                        </p:attrNameLst>
+                                      </p:cBhvr>
+                                      <p:tavLst>
+                                        <p:tav tm="0">
+                                          <p:val>
+                                            <p:strVal val="#ppt_x"/>
+                                          </p:val>
+                                        </p:tav>
+                                        <p:tav tm="100000">
+                                          <p:val>
+                                            <p:strVal val="#ppt_x"/>
+                                          </p:val>
+                                        </p:tav>
+                                      </p:tavLst>
+                                    </p:anim>
+                                    <p:anim calcmode="lin" valueType="num">
+                                      <p:cBhvr>
+                                        <p:cTn id="119" dur="600" decel="100000" fill="hold"/>
+                                        <p:tgtEl>
+                                          <p:spTgt spid="24"/>
+                                        </p:tgtEl>
+                                        <p:attrNameLst>
+                                          <p:attrName>ppt_y</p:attrName>
+                                        </p:attrNameLst>
+                                      </p:cBhvr>
+                                      <p:tavLst>
+                                        <p:tav tm="0">
+                                          <p:val>
+                                            <p:strVal val="#ppt_y+0.0333"/>
+                                          </p:val>
+                                        </p:tav>
+                                        <p:tav tm="100000">
+                                          <p:val>
+                                            <p:strVal val="#ppt_y"/>
+                                          </p:val>
+                                        </p:tav>
+                                      </p:tavLst>
+                                    </p:anim>
+                                  </p:childTnLst>
+                                </p:cTn>
+                              </p:par>
+                              <p:par>
+                                <p:cTn id="120" presetID="42" presetClass="entr" presetSubtype="0" fill="hold" grpId="0" nodeType="withEffect">
+                                  <p:stCondLst>
+                                    <p:cond delay="330"/>
+                                  </p:stCondLst>
+                                  <p:childTnLst>
+                                    <p:set>
+                                      <p:cBhvr>
+                                        <p:cTn id="121" dur="1" fill="hold">
+                                          <p:stCondLst>
+                                            <p:cond delay="0"/>
+                                          </p:stCondLst>
+                                        </p:cTn>
+                                        <p:tgtEl>
+                                          <p:spTgt spid="25"/>
+                                        </p:tgtEl>
+                                        <p:attrNameLst>
+                                          <p:attrName>style.visibility</p:attrName>
+                                        </p:attrNameLst>
+                                      </p:cBhvr>
+                                      <p:to>
+                                        <p:strVal val="visible"/>
+                                      </p:to>
+                                    </p:set>
+                                    <p:animEffect transition="in" filter="fade">
+                                      <p:cBhvr>
+                                        <p:cTn id="122" dur="600"/>
+                                        <p:tgtEl>
+                                          <p:spTgt spid="25"/>
+                                        </p:tgtEl>
+                                      </p:cBhvr>
+                                    </p:animEffect>
+                                    <p:anim calcmode="lin" valueType="num">
+                                      <p:cBhvr>
+                                        <p:cTn id="123" dur="600" decel="100000" fill="hold"/>
+                                        <p:tgtEl>
+                                          <p:spTgt spid="25"/>
+                                        </p:tgtEl>
+                                        <p:attrNameLst>
+                                          <p:attrName>ppt_x</p:attrName>
+                                        </p:attrNameLst>
+                                      </p:cBhvr>
+                                      <p:tavLst>
+                                        <p:tav tm="0">
+                                          <p:val>
+                                            <p:strVal val="#ppt_x"/>
+                                          </p:val>
+                                        </p:tav>
+                                        <p:tav tm="100000">
+                                          <p:val>
+                                            <p:strVal val="#ppt_x"/>
+                                          </p:val>
+                                        </p:tav>
+                                      </p:tavLst>
+                                    </p:anim>
+                                    <p:anim calcmode="lin" valueType="num">
+                                      <p:cBhvr>
+                                        <p:cTn id="124" dur="600" decel="100000" fill="hold"/>
+                                        <p:tgtEl>
+                                          <p:spTgt spid="25"/>
+                                        </p:tgtEl>
+                                        <p:attrNameLst>
+                                          <p:attrName>ppt_y</p:attrName>
+                                        </p:attrNameLst>
+                                      </p:cBhvr>
+                                      <p:tavLst>
+                                        <p:tav tm="0">
+                                          <p:val>
+                                            <p:strVal val="#ppt_y+0.0333"/>
+                                          </p:val>
+                                        </p:tav>
+                                        <p:tav tm="100000">
+                                          <p:val>
+                                            <p:strVal val="#ppt_y"/>
+                                          </p:val>
+                                        </p:tav>
+                                      </p:tavLst>
+                                    </p:anim>
+                                  </p:childTnLst>
+                                </p:cTn>
+                              </p:par>
+                              <p:par>
+                                <p:cTn id="125" presetID="42" presetClass="entr" presetSubtype="0" fill="hold" grpId="0" nodeType="withEffect">
+                                  <p:stCondLst>
+                                    <p:cond delay="330"/>
+                                  </p:stCondLst>
+                                  <p:childTnLst>
+                                    <p:set>
+                                      <p:cBhvr>
+                                        <p:cTn id="126" dur="1" fill="hold">
+                                          <p:stCondLst>
+                                            <p:cond delay="0"/>
+                                          </p:stCondLst>
+                                        </p:cTn>
+                                        <p:tgtEl>
+                                          <p:spTgt spid="26"/>
+                                        </p:tgtEl>
+                                        <p:attrNameLst>
+                                          <p:attrName>style.visibility</p:attrName>
+                                        </p:attrNameLst>
+                                      </p:cBhvr>
+                                      <p:to>
+                                        <p:strVal val="visible"/>
+                                      </p:to>
+                                    </p:set>
+                                    <p:animEffect transition="in" filter="fade">
+                                      <p:cBhvr>
+                                        <p:cTn id="127" dur="600"/>
+                                        <p:tgtEl>
+                                          <p:spTgt spid="26"/>
+                                        </p:tgtEl>
+                                      </p:cBhvr>
+                                    </p:animEffect>
+                                    <p:anim calcmode="lin" valueType="num">
+                                      <p:cBhvr>
+                                        <p:cTn id="128" dur="600" decel="100000" fill="hold"/>
+                                        <p:tgtEl>
+                                          <p:spTgt spid="26"/>
+                                        </p:tgtEl>
+                                        <p:attrNameLst>
+                                          <p:attrName>ppt_x</p:attrName>
+                                        </p:attrNameLst>
+                                      </p:cBhvr>
+                                      <p:tavLst>
+                                        <p:tav tm="0">
+                                          <p:val>
+                                            <p:strVal val="#ppt_x"/>
+                                          </p:val>
+                                        </p:tav>
+                                        <p:tav tm="100000">
+                                          <p:val>
+                                            <p:strVal val="#ppt_x"/>
+                                          </p:val>
+                                        </p:tav>
+                                      </p:tavLst>
+                                    </p:anim>
+                                    <p:anim calcmode="lin" valueType="num">
+                                      <p:cBhvr>
+                                        <p:cTn id="129" dur="600" decel="100000" fill="hold"/>
+                                        <p:tgtEl>
+                                          <p:spTgt spid="26"/>
+                                        </p:tgtEl>
+                                        <p:attrNameLst>
+                                          <p:attrName>ppt_y</p:attrName>
+                                        </p:attrNameLst>
+                                      </p:cBhvr>
+                                      <p:tavLst>
+                                        <p:tav tm="0">
+                                          <p:val>
+                                            <p:strVal val="#ppt_y+0.0333"/>
+                                          </p:val>
+                                        </p:tav>
+                                        <p:tav tm="100000">
+                                          <p:val>
+                                            <p:strVal val="#ppt_y"/>
+                                          </p:val>
+                                        </p:tav>
+                                      </p:tavLst>
+                                    </p:anim>
+                                  </p:childTnLst>
+                                </p:cTn>
+                              </p:par>
+                              <p:par>
+                                <p:cTn id="130" presetID="42" presetClass="entr" presetSubtype="0" fill="hold" grpId="0" nodeType="withEffect">
+                                  <p:stCondLst>
+                                    <p:cond delay="330"/>
+                                  </p:stCondLst>
+                                  <p:childTnLst>
+                                    <p:set>
+                                      <p:cBhvr>
+                                        <p:cTn id="131" dur="1" fill="hold">
+                                          <p:stCondLst>
+                                            <p:cond delay="0"/>
+                                          </p:stCondLst>
+                                        </p:cTn>
+                                        <p:tgtEl>
+                                          <p:spTgt spid="27"/>
+                                        </p:tgtEl>
+                                        <p:attrNameLst>
+                                          <p:attrName>style.visibility</p:attrName>
+                                        </p:attrNameLst>
+                                      </p:cBhvr>
+                                      <p:to>
+                                        <p:strVal val="visible"/>
+                                      </p:to>
+                                    </p:set>
+                                    <p:animEffect transition="in" filter="fade">
+                                      <p:cBhvr>
+                                        <p:cTn id="132" dur="600"/>
+                                        <p:tgtEl>
+                                          <p:spTgt spid="27"/>
+                                        </p:tgtEl>
+                                      </p:cBhvr>
+                                    </p:animEffect>
+                                    <p:anim calcmode="lin" valueType="num">
+                                      <p:cBhvr>
+                                        <p:cTn id="133" dur="600" decel="100000" fill="hold"/>
+                                        <p:tgtEl>
+                                          <p:spTgt spid="27"/>
+                                        </p:tgtEl>
+                                        <p:attrNameLst>
+                                          <p:attrName>ppt_x</p:attrName>
+                                        </p:attrNameLst>
+                                      </p:cBhvr>
+                                      <p:tavLst>
+                                        <p:tav tm="0">
+                                          <p:val>
+                                            <p:strVal val="#ppt_x"/>
+                                          </p:val>
+                                        </p:tav>
+                                        <p:tav tm="100000">
+                                          <p:val>
+                                            <p:strVal val="#ppt_x"/>
+                                          </p:val>
+                                        </p:tav>
+                                      </p:tavLst>
+                                    </p:anim>
+                                    <p:anim calcmode="lin" valueType="num">
+                                      <p:cBhvr>
+                                        <p:cTn id="134" dur="600" decel="100000" fill="hold"/>
+                                        <p:tgtEl>
+                                          <p:spTgt spid="27"/>
+                                        </p:tgtEl>
+                                        <p:attrNameLst>
+                                          <p:attrName>ppt_y</p:attrName>
+                                        </p:attrNameLst>
+                                      </p:cBhvr>
+                                      <p:tavLst>
+                                        <p:tav tm="0">
+                                          <p:val>
+                                            <p:strVal val="#ppt_y+0.0333"/>
+                                          </p:val>
+                                        </p:tav>
+                                        <p:tav tm="100000">
+                                          <p:val>
+                                            <p:strVal val="#ppt_y"/>
+                                          </p:val>
+                                        </p:tav>
+                                      </p:tavLst>
+                                    </p:anim>
+                                  </p:childTnLst>
+                                </p:cTn>
+                              </p:par>
                             </p:childTnLst>
                           </p:cTn>
                         </p:par>
@@ -19080,6 +19704,12 @@
       <p:bldP spid="19" grpId="0" animBg="1"/>
       <p:bldP spid="20" grpId="0" animBg="1"/>
       <p:bldP spid="21" grpId="0" animBg="1"/>
+      <p:bldP spid="22" grpId="0" animBg="1"/>
+      <p:bldP spid="23" grpId="0" animBg="1"/>
+      <p:bldP spid="24" grpId="0" animBg="1"/>
+      <p:bldP spid="25" grpId="0" animBg="1"/>
+      <p:bldP spid="26" grpId="0" animBg="1"/>
+      <p:bldP spid="27" grpId="0" animBg="1"/>
     </p:bldLst>
   </p:timing>
 </p:sld>

</xml_diff>

<commit_message>
doc: re-render showcase with the reordered Nitro stack
</commit_message>
<xml_diff>
--- a/examples/showcase/decks/ec2-intro/what-is-amazon-ec2.pptx
+++ b/examples/showcase/decks/ec2-intro/what-is-amazon-ec2.pptx
@@ -25547,34 +25547,51 @@
         </p:nvSpPr>
         <p:spPr>
           <a:xfrm>
-            <a:off x="990600" y="1932533"/>
-            <a:ext cx="1047750" cy="914400"/>
+            <a:off x="609600" y="5075783"/>
+            <a:ext cx="5334000" cy="914400"/>
           </a:xfrm>
           <a:prstGeom prst="cube">
             <a:avLst/>
           </a:prstGeom>
           <a:solidFill>
-            <a:schemeClr val="accent4">
-              <a:lumMod val="30000"/>
-              <a:lumOff val="70000"/>
-            </a:schemeClr>
+            <a:schemeClr val="tx1"/>
           </a:solidFill>
-          <a:ln w="9525">
-            <a:solidFill>
-              <a:schemeClr val="accent4">
-                <a:lumMod val="60000"/>
-                <a:lumOff val="40000"/>
-              </a:schemeClr>
-            </a:solidFill>
-            <a:prstDash val="solid"/>
+          <a:ln>
+            <a:noFill/>
           </a:ln>
         </p:spPr>
         <p:txBody>
-          <a:bodyPr wrap="square" lIns="0" tIns="0" rIns="0" bIns="0" anchor="t">
+          <a:bodyPr wrap="square" lIns="228600" tIns="228600" rIns="228600" bIns="228600" anchor="t">
             <a:normAutofit/>
           </a:bodyPr>
           <a:lstStyle/>
-          <a:p/>
+          <a:p>
+            <a:pPr algn="l">
+              <a:lnSpc>
+                <a:spcPts val="2025"/>
+              </a:lnSpc>
+            </a:pPr>
+            <a:r>
+              <a:rPr sz="1350" b="1" i="0" u="none">
+                <a:solidFill>
+                  <a:schemeClr val="bg1"/>
+                </a:solidFill>
+                <a:latin typeface="+mn-lt"/>
+                <a:ea typeface="+mn-ea"/>
+              </a:rPr>
+              <a:t>Host hardware</a:t>
+            </a:r>
+            <a:r>
+              <a:rPr sz="1350" b="0">
+                <a:solidFill>
+                  <a:schemeClr val="bg1"/>
+                </a:solidFill>
+                <a:latin typeface="+mn-lt"/>
+                <a:ea typeface="+mn-ea"/>
+              </a:rPr>
+              <a:t> — Graviton · Intel · AMD · GPUs</a:t>
+            </a:r>
+          </a:p>
         </p:txBody>
       </p:sp>
       <p:sp>
@@ -25585,34 +25602,51 @@
         </p:nvSpPr>
         <p:spPr>
           <a:xfrm>
-            <a:off x="2324100" y="1932533"/>
-            <a:ext cx="1047750" cy="914400"/>
+            <a:off x="609600" y="4313783"/>
+            <a:ext cx="5334000" cy="914400"/>
           </a:xfrm>
           <a:prstGeom prst="cube">
             <a:avLst/>
           </a:prstGeom>
           <a:solidFill>
-            <a:schemeClr val="accent4">
-              <a:lumMod val="30000"/>
-              <a:lumOff val="70000"/>
-            </a:schemeClr>
+            <a:schemeClr val="accent1"/>
           </a:solidFill>
-          <a:ln w="9525">
-            <a:solidFill>
-              <a:schemeClr val="accent4">
-                <a:lumMod val="60000"/>
-                <a:lumOff val="40000"/>
-              </a:schemeClr>
-            </a:solidFill>
-            <a:prstDash val="solid"/>
+          <a:ln>
+            <a:noFill/>
           </a:ln>
         </p:spPr>
         <p:txBody>
-          <a:bodyPr wrap="square" lIns="0" tIns="0" rIns="0" bIns="0" anchor="t">
+          <a:bodyPr wrap="square" lIns="228600" tIns="228600" rIns="228600" bIns="228600" anchor="t">
             <a:normAutofit/>
           </a:bodyPr>
           <a:lstStyle/>
-          <a:p/>
+          <a:p>
+            <a:pPr algn="l">
+              <a:lnSpc>
+                <a:spcPts val="2025"/>
+              </a:lnSpc>
+            </a:pPr>
+            <a:r>
+              <a:rPr sz="1350" b="1" i="0" u="none">
+                <a:solidFill>
+                  <a:schemeClr val="bg1"/>
+                </a:solidFill>
+                <a:latin typeface="+mn-lt"/>
+                <a:ea typeface="+mn-ea"/>
+              </a:rPr>
+              <a:t>Nitro Cards</a:t>
+            </a:r>
+            <a:r>
+              <a:rPr sz="1350" b="0">
+                <a:solidFill>
+                  <a:schemeClr val="bg1"/>
+                </a:solidFill>
+                <a:latin typeface="+mn-lt"/>
+                <a:ea typeface="+mn-ea"/>
+              </a:rPr>
+              <a:t> — VPC · EBS · instance storage</a:t>
+            </a:r>
+          </a:p>
         </p:txBody>
       </p:sp>
       <p:sp>
@@ -25623,34 +25657,51 @@
         </p:nvSpPr>
         <p:spPr>
           <a:xfrm>
-            <a:off x="3657600" y="1932533"/>
-            <a:ext cx="1047750" cy="914400"/>
+            <a:off x="609600" y="3551783"/>
+            <a:ext cx="5334000" cy="914400"/>
           </a:xfrm>
           <a:prstGeom prst="cube">
             <a:avLst/>
           </a:prstGeom>
           <a:solidFill>
-            <a:schemeClr val="accent4">
-              <a:lumMod val="30000"/>
-              <a:lumOff val="70000"/>
-            </a:schemeClr>
+            <a:schemeClr val="accent5"/>
           </a:solidFill>
-          <a:ln w="9525">
-            <a:solidFill>
-              <a:schemeClr val="accent4">
-                <a:lumMod val="60000"/>
-                <a:lumOff val="40000"/>
-              </a:schemeClr>
-            </a:solidFill>
-            <a:prstDash val="solid"/>
+          <a:ln>
+            <a:noFill/>
           </a:ln>
         </p:spPr>
         <p:txBody>
-          <a:bodyPr wrap="square" lIns="0" tIns="0" rIns="0" bIns="0" anchor="t">
+          <a:bodyPr wrap="square" lIns="228600" tIns="228600" rIns="228600" bIns="228600" anchor="t">
             <a:normAutofit/>
           </a:bodyPr>
           <a:lstStyle/>
-          <a:p/>
+          <a:p>
+            <a:pPr algn="l">
+              <a:lnSpc>
+                <a:spcPts val="2025"/>
+              </a:lnSpc>
+            </a:pPr>
+            <a:r>
+              <a:rPr sz="1350" b="1" i="0" u="none">
+                <a:solidFill>
+                  <a:schemeClr val="bg1"/>
+                </a:solidFill>
+                <a:latin typeface="+mn-lt"/>
+                <a:ea typeface="+mn-ea"/>
+              </a:rPr>
+              <a:t>Nitro Security Chip</a:t>
+            </a:r>
+            <a:r>
+              <a:rPr sz="1350" b="0">
+                <a:solidFill>
+                  <a:schemeClr val="bg1"/>
+                </a:solidFill>
+                <a:latin typeface="+mn-lt"/>
+                <a:ea typeface="+mn-ea"/>
+              </a:rPr>
+              <a:t> — hardware root of trust</a:t>
+            </a:r>
+          </a:p>
         </p:txBody>
       </p:sp>
       <p:sp>
@@ -25716,51 +25767,34 @@
         </p:nvSpPr>
         <p:spPr>
           <a:xfrm>
-            <a:off x="609600" y="3551783"/>
-            <a:ext cx="5334000" cy="914400"/>
+            <a:off x="990600" y="2065883"/>
+            <a:ext cx="1047750" cy="914400"/>
           </a:xfrm>
           <a:prstGeom prst="cube">
             <a:avLst/>
           </a:prstGeom>
           <a:solidFill>
-            <a:schemeClr val="accent5"/>
+            <a:schemeClr val="accent4">
+              <a:lumMod val="30000"/>
+              <a:lumOff val="70000"/>
+            </a:schemeClr>
           </a:solidFill>
-          <a:ln>
-            <a:noFill/>
+          <a:ln w="9525">
+            <a:solidFill>
+              <a:schemeClr val="accent4">
+                <a:lumMod val="60000"/>
+                <a:lumOff val="40000"/>
+              </a:schemeClr>
+            </a:solidFill>
+            <a:prstDash val="solid"/>
           </a:ln>
         </p:spPr>
         <p:txBody>
-          <a:bodyPr wrap="square" lIns="228600" tIns="228600" rIns="228600" bIns="228600" anchor="t">
+          <a:bodyPr wrap="square" lIns="0" tIns="0" rIns="0" bIns="0" anchor="t">
             <a:normAutofit/>
           </a:bodyPr>
           <a:lstStyle/>
-          <a:p>
-            <a:pPr algn="l">
-              <a:lnSpc>
-                <a:spcPts val="2025"/>
-              </a:lnSpc>
-            </a:pPr>
-            <a:r>
-              <a:rPr sz="1350" b="1" i="0" u="none">
-                <a:solidFill>
-                  <a:schemeClr val="bg1"/>
-                </a:solidFill>
-                <a:latin typeface="+mn-lt"/>
-                <a:ea typeface="+mn-ea"/>
-              </a:rPr>
-              <a:t>Nitro Security Chip</a:t>
-            </a:r>
-            <a:r>
-              <a:rPr sz="1350" b="0">
-                <a:solidFill>
-                  <a:schemeClr val="bg1"/>
-                </a:solidFill>
-                <a:latin typeface="+mn-lt"/>
-                <a:ea typeface="+mn-ea"/>
-              </a:rPr>
-              <a:t> — hardware root of trust</a:t>
-            </a:r>
-          </a:p>
+          <a:p/>
         </p:txBody>
       </p:sp>
       <p:sp>
@@ -25771,51 +25805,34 @@
         </p:nvSpPr>
         <p:spPr>
           <a:xfrm>
-            <a:off x="609600" y="4313783"/>
-            <a:ext cx="5334000" cy="914400"/>
+            <a:off x="2324100" y="2065883"/>
+            <a:ext cx="1047750" cy="914400"/>
           </a:xfrm>
           <a:prstGeom prst="cube">
             <a:avLst/>
           </a:prstGeom>
           <a:solidFill>
-            <a:schemeClr val="accent1"/>
+            <a:schemeClr val="accent4">
+              <a:lumMod val="30000"/>
+              <a:lumOff val="70000"/>
+            </a:schemeClr>
           </a:solidFill>
-          <a:ln>
-            <a:noFill/>
+          <a:ln w="9525">
+            <a:solidFill>
+              <a:schemeClr val="accent4">
+                <a:lumMod val="60000"/>
+                <a:lumOff val="40000"/>
+              </a:schemeClr>
+            </a:solidFill>
+            <a:prstDash val="solid"/>
           </a:ln>
         </p:spPr>
         <p:txBody>
-          <a:bodyPr wrap="square" lIns="228600" tIns="228600" rIns="228600" bIns="228600" anchor="t">
+          <a:bodyPr wrap="square" lIns="0" tIns="0" rIns="0" bIns="0" anchor="t">
             <a:normAutofit/>
           </a:bodyPr>
           <a:lstStyle/>
-          <a:p>
-            <a:pPr algn="l">
-              <a:lnSpc>
-                <a:spcPts val="2025"/>
-              </a:lnSpc>
-            </a:pPr>
-            <a:r>
-              <a:rPr sz="1350" b="1" i="0" u="none">
-                <a:solidFill>
-                  <a:schemeClr val="bg1"/>
-                </a:solidFill>
-                <a:latin typeface="+mn-lt"/>
-                <a:ea typeface="+mn-ea"/>
-              </a:rPr>
-              <a:t>Nitro Cards</a:t>
-            </a:r>
-            <a:r>
-              <a:rPr sz="1350" b="0">
-                <a:solidFill>
-                  <a:schemeClr val="bg1"/>
-                </a:solidFill>
-                <a:latin typeface="+mn-lt"/>
-                <a:ea typeface="+mn-ea"/>
-              </a:rPr>
-              <a:t> — VPC · EBS · instance storage</a:t>
-            </a:r>
-          </a:p>
+          <a:p/>
         </p:txBody>
       </p:sp>
       <p:sp>
@@ -25826,51 +25843,34 @@
         </p:nvSpPr>
         <p:spPr>
           <a:xfrm>
-            <a:off x="609600" y="5075783"/>
-            <a:ext cx="5334000" cy="914400"/>
+            <a:off x="3657600" y="2065883"/>
+            <a:ext cx="1047750" cy="914400"/>
           </a:xfrm>
           <a:prstGeom prst="cube">
             <a:avLst/>
           </a:prstGeom>
           <a:solidFill>
-            <a:schemeClr val="tx1"/>
+            <a:schemeClr val="accent4">
+              <a:lumMod val="30000"/>
+              <a:lumOff val="70000"/>
+            </a:schemeClr>
           </a:solidFill>
-          <a:ln>
-            <a:noFill/>
+          <a:ln w="9525">
+            <a:solidFill>
+              <a:schemeClr val="accent4">
+                <a:lumMod val="60000"/>
+                <a:lumOff val="40000"/>
+              </a:schemeClr>
+            </a:solidFill>
+            <a:prstDash val="solid"/>
           </a:ln>
         </p:spPr>
         <p:txBody>
-          <a:bodyPr wrap="square" lIns="228600" tIns="228600" rIns="228600" bIns="228600" anchor="t">
+          <a:bodyPr wrap="square" lIns="0" tIns="0" rIns="0" bIns="0" anchor="t">
             <a:normAutofit/>
           </a:bodyPr>
           <a:lstStyle/>
-          <a:p>
-            <a:pPr algn="l">
-              <a:lnSpc>
-                <a:spcPts val="2025"/>
-              </a:lnSpc>
-            </a:pPr>
-            <a:r>
-              <a:rPr sz="1350" b="1" i="0" u="none">
-                <a:solidFill>
-                  <a:schemeClr val="bg1"/>
-                </a:solidFill>
-                <a:latin typeface="+mn-lt"/>
-                <a:ea typeface="+mn-ea"/>
-              </a:rPr>
-              <a:t>Host hardware</a:t>
-            </a:r>
-            <a:r>
-              <a:rPr sz="1350" b="0">
-                <a:solidFill>
-                  <a:schemeClr val="bg1"/>
-                </a:solidFill>
-                <a:latin typeface="+mn-lt"/>
-                <a:ea typeface="+mn-ea"/>
-              </a:rPr>
-              <a:t> — Graviton · Intel · AMD · GPUs</a:t>
-            </a:r>
-          </a:p>
+          <a:p/>
         </p:txBody>
       </p:sp>
       <p:sp>

</xml_diff>